<commit_message>
docs: refresh decks and architecture diagrams to v0.13.0
Reflect the features shipped in v0.12.0-v0.13.0 across the leadership deck,
one-pager, and the four architecture SVGs:

- counts 16 -> 17 skills, 4 -> 5 agents; version 0.11.0 -> 0.13.0
- migration-critic agent + /quality-check; behavioural-parity + security gate;
  toolchain preflight; exhaustive /analyze discovery; /plan dependency graph;
  /status artifact-drift staleness
- build_presentation.py + build_onepager_v2.py edited; both pptx regenerated
  via python-pptx
- web-migrate + architecture-p2 redrawn (5 agents, 17 skills); p1 + p3 updated;
  also fixed pre-existing framework-count errors in p2 (now 17 source / 8 ui /
  6 api)

Co-Authored-By: Claude Opus 4.8 (1M context) <noreply@anthropic.com>
</commit_message>
<xml_diff>
--- a/docs/decks/web-modernize-onepager-v2.pptx
+++ b/docs/decks/web-modernize-onepager-v2.pptx
@@ -5220,7 +5220,7 @@
                 </a:solidFill>
                 <a:latin typeface="Calibri"/>
               </a:rPr>
-              <a:t>One workflow + a /verify gate (lint, types, tests, parity). Undo a unit with /rollback; redo with /retry.</a:t>
+              <a:t>One workflow + a /verify gate (lint · types · tests · parity · security). Undo with /rollback; redo with /retry.</a:t>
             </a:r>
           </a:p>
         </p:txBody>
@@ -5779,7 +5779,7 @@
                 </a:solidFill>
                 <a:latin typeface="Calibri"/>
               </a:rPr>
-              <a:t>Same Claude Code engine.  A structured, sprint-by-sprint migration workflow on top.        Balaji Harikrishnan · Cognizant · v0.11.0</a:t>
+              <a:t>Same Claude Code engine.  A structured, sprint-by-sprint migration workflow on top.        Balaji Harikrishnan · Cognizant · v0.13.0</a:t>
             </a:r>
           </a:p>
         </p:txBody>

</xml_diff>